<commit_message>
Level 5 Lesson 1 draft listening audio (1:37)
</commit_message>
<xml_diff>
--- a/level5/slides/Level5_Lesson1_Slides.pptx
+++ b/level5/slides/Level5_Lesson1_Slides.pptx
@@ -536,7 +536,7 @@
           </a:p>
           <a:p>
             <a:r>
-              <a:t>Audio: the listening audio for this lesson (about 2:10) is coming soon. It will use computer-generated voices (Chatterbox TTS cloned from synthetic Kokoro-82M reference clips); no recordings of real people. Until it is ready, read the listening script (in the notes of the Before You Listen slide) with a volunteer. The names and the story are invented.</a:t>
+              <a:t>Audio: synthetic voices, computer-generated (Chatterbox TTS cloned from Kokoro-82M reference clips). No recordings of real people. The names and the story are invented.</a:t>
             </a:r>
           </a:p>
           <a:p>
@@ -1417,111 +1417,6 @@
           <a:p>
             <a:r>
               <a:t>Picture: Twemoji graphics by Twitter, Inc. and other contributors (https://github.com/jdecked/twemoji), CC BY 4.0 (https://creativecommons.org/licenses/by/4.0/); resized and combined, with signs and labels (images/CREDITS.md).</a:t>
-            </a:r>
-          </a:p>
-          <a:p>
-            <a:r>
-              <a:t>Listening script (the audio is coming soon; until then, read it aloud with a volunteer at a normal, friendly speed):</a:t>
-            </a:r>
-          </a:p>
-          <a:p>
-            <a:r>
-              <a:t>Narrator: Lesson one. The community center is holding a practice interview night. Nora wants a hotel front-desk job.</a:t>
-            </a:r>
-          </a:p>
-          <a:p>
-            <a:r>
-              <a:t>Samir: Hi, Nora. I'm Samir, your coach. Are you ready to practice?</a:t>
-            </a:r>
-          </a:p>
-          <a:p>
-            <a:r>
-              <a:t>Nora: Yes. I want to practice for a front-desk job at the Harbor Hotel.</a:t>
-            </a:r>
-          </a:p>
-          <a:p>
-            <a:r>
-              <a:t>Samir: Good. Ms. Hale is going to ask the questions. I am going to take notes.</a:t>
-            </a:r>
-          </a:p>
-          <a:p>
-            <a:r>
-              <a:t>Ms. Hale: Welcome, Nora. How long have you been working with customers?</a:t>
-            </a:r>
-          </a:p>
-          <a:p>
-            <a:r>
-              <a:t>Nora: I've been working with customers for three years. I work at a store now.</a:t>
-            </a:r>
-          </a:p>
-          <a:p>
-            <a:r>
-              <a:t>Ms. Hale: Tell me one accomplishment.</a:t>
-            </a:r>
-          </a:p>
-          <a:p>
-            <a:r>
-              <a:t>Nora: I trained two new cashiers last spring.</a:t>
-            </a:r>
-          </a:p>
-          <a:p>
-            <a:r>
-              <a:t>Ms. Hale: Can you give an example?</a:t>
-            </a:r>
-          </a:p>
-          <a:p>
-            <a:r>
-              <a:t>Nora: Yes. One new cashier was nervous. I stayed with her for a week.</a:t>
-            </a:r>
-          </a:p>
-          <a:p>
-            <a:r>
-              <a:t>Ms. Hale: Have you finished any hotel training?</a:t>
-            </a:r>
-          </a:p>
-          <a:p>
-            <a:r>
-              <a:t>Nora: Not yet. I want to start the front-desk training next month.</a:t>
-            </a:r>
-          </a:p>
-          <a:p>
-            <a:r>
-              <a:t>Samir: That example was clear. You said, "I've been working."</a:t>
-            </a:r>
-          </a:p>
-          <a:p>
-            <a:r>
-              <a:t>Ms. Hale: What did you do in 2022?</a:t>
-            </a:r>
-          </a:p>
-          <a:p>
-            <a:r>
-              <a:t>Nora: I worked at a bakery in 2022. That job is finished.</a:t>
-            </a:r>
-          </a:p>
-          <a:p>
-            <a:r>
-              <a:t>Ms. Hale: Do you have a follow-up question?</a:t>
-            </a:r>
-          </a:p>
-          <a:p>
-            <a:r>
-              <a:t>Nora: Yes. What do you send after the interview?</a:t>
-            </a:r>
-          </a:p>
-          <a:p>
-            <a:r>
-              <a:t>Ms. Hale: A short note. A handshake and a thank-you are a good start.</a:t>
-            </a:r>
-          </a:p>
-          <a:p>
-            <a:r>
-              <a:t>Samir: Next, you are going to put one accomplishment in your portfolio.</a:t>
-            </a:r>
-          </a:p>
-          <a:p>
-            <a:r>
-              <a:t>Narrator: That's the end of the listening.</a:t>
             </a:r>
           </a:p>
         </p:txBody>
@@ -11023,7 +10918,7 @@
                 <a:ea typeface="Lexend Deca" pitchFamily="34" charset="-122"/>
                 <a:cs typeface="Lexend Deca" pitchFamily="34" charset="-120"/>
               </a:rPr>
-              <a:t>Audio (about 2:10): coming soon.</a:t>
+              <a:t>Audio: about 1:37. It plays once.</a:t>
             </a:r>
             <a:endParaRPr lang="en-US" sz="2200" dirty="0"/>
           </a:p>
@@ -28493,7 +28388,7 @@
                 <a:ea typeface="Lexend Deca" pitchFamily="34" charset="-122"/>
                 <a:cs typeface="Lexend Deca" pitchFamily="34" charset="-120"/>
               </a:rPr>
-              <a:t>Audio (coming soon): synthetic voices made with Chatterbox TTS (MIT License), cloned from short synthetic reference clips made with Kokoro-82M (Apache License 2.0). No recordings of real people. Each file will carry an inaudible Perth watermark marking it as AI-generated. Font: Lexend Deca (OFL 1.1).</a:t>
+              <a:t>Audio: synthetic voices made with Chatterbox TTS (MIT License), cloned from short synthetic reference clips made with Kokoro-82M (Apache License 2.0). No recordings of real people were used. Each file carries an inaudible Perth watermark marking it as AI-generated. Font: Lexend Deca (OFL 1.1).</a:t>
             </a:r>
             <a:endParaRPr lang="en-US" sz="1350" dirty="0" b="0"/>
           </a:p>

</xml_diff>